<commit_message>
Actividades de la unidad 5
</commit_message>
<xml_diff>
--- a/Actividad 5.2 Reporte de práctica_AlanRodríguez_ABD_6ISCM.pptx
+++ b/Actividad 5.2 Reporte de práctica_AlanRodríguez_ABD_6ISCM.pptx
@@ -282,7 +282,7 @@
           <a:p>
             <a:fld id="{446A0C85-3213-4D26-8282-A0CD864DABC2}" type="datetimeFigureOut">
               <a:rPr lang="es-MX" smtClean="0"/>
-              <a:t>13/06/2026</a:t>
+              <a:t>15/06/2026</a:t>
             </a:fld>
             <a:endParaRPr lang="es-MX"/>
           </a:p>
@@ -668,7 +668,7 @@
           <a:p>
             <a:fld id="{1D8BD707-D9CF-40AE-B4C6-C98DA3205C09}" type="datetimeFigureOut">
               <a:rPr lang="en-US" smtClean="0"/>
-              <a:t>6/13/2026</a:t>
+              <a:t>6/15/2026</a:t>
             </a:fld>
             <a:endParaRPr lang="en-US"/>
           </a:p>
@@ -875,7 +875,7 @@
           <a:p>
             <a:fld id="{1D8BD707-D9CF-40AE-B4C6-C98DA3205C09}" type="datetimeFigureOut">
               <a:rPr lang="en-US" smtClean="0"/>
-              <a:t>6/13/2026</a:t>
+              <a:t>6/15/2026</a:t>
             </a:fld>
             <a:endParaRPr lang="en-US"/>
           </a:p>
@@ -18407,7 +18407,7 @@
               </a:lnSpc>
             </a:pPr>
             <a:r>
-              <a:rPr lang="es-MX" sz="3000">
+              <a:rPr lang="es-MX" sz="3000" dirty="0">
                 <a:solidFill>
                   <a:srgbClr val="253754"/>
                 </a:solidFill>
@@ -18441,6 +18441,19 @@
                 <a:spcPts val="3750"/>
               </a:lnSpc>
             </a:pPr>
+            <a:r>
+              <a:rPr lang="en-US" sz="3000" dirty="0">
+                <a:solidFill>
+                  <a:srgbClr val="253754"/>
+                </a:solidFill>
+                <a:latin typeface="Glacial Indifference"/>
+                <a:ea typeface="Glacial Indifference"/>
+                <a:cs typeface="Glacial Indifference"/>
+                <a:sym typeface="Glacial Indifference"/>
+                <a:hlinkClick r:id="rId2"/>
+              </a:rPr>
+              <a:t>https://github.com/Alan-Rodriguez0/ABD-Tema-5.git</a:t>
+            </a:r>
             <a:endParaRPr lang="en-US" sz="3000" dirty="0">
               <a:solidFill>
                 <a:srgbClr val="253754"/>
@@ -18457,19 +18470,6 @@
                 <a:spcPts val="3750"/>
               </a:lnSpc>
             </a:pPr>
-            <a:r>
-              <a:rPr lang="en-US" sz="3000" dirty="0">
-                <a:solidFill>
-                  <a:srgbClr val="253754"/>
-                </a:solidFill>
-                <a:latin typeface="Glacial Indifference"/>
-                <a:ea typeface="Glacial Indifference"/>
-                <a:cs typeface="Glacial Indifference"/>
-                <a:sym typeface="Glacial Indifference"/>
-                <a:hlinkClick r:id="rId2"/>
-              </a:rPr>
-              <a:t>https://github.com/Alan-Rodriguez0/TBD-Unidad-6.git</a:t>
-            </a:r>
             <a:endParaRPr lang="en-US" sz="3000" dirty="0">
               <a:solidFill>
                 <a:srgbClr val="253754"/>
@@ -18685,6 +18685,36 @@
           </p:txBody>
         </p:sp>
       </p:grpSp>
+      <p:pic>
+        <p:nvPicPr>
+          <p:cNvPr id="10" name="Imagen 9">
+            <a:extLst>
+              <a:ext uri="{FF2B5EF4-FFF2-40B4-BE49-F238E27FC236}">
+                <a16:creationId xmlns:a16="http://schemas.microsoft.com/office/drawing/2014/main" id="{2407F55A-B0DF-4162-901C-6855776EF19E}"/>
+              </a:ext>
+            </a:extLst>
+          </p:cNvPr>
+          <p:cNvPicPr>
+            <a:picLocks noChangeAspect="1"/>
+          </p:cNvPicPr>
+          <p:nvPr/>
+        </p:nvPicPr>
+        <p:blipFill>
+          <a:blip r:embed="rId3"/>
+          <a:stretch>
+            <a:fillRect/>
+          </a:stretch>
+        </p:blipFill>
+        <p:spPr>
+          <a:xfrm>
+            <a:off x="3276600" y="1409700"/>
+            <a:ext cx="11734800" cy="6600825"/>
+          </a:xfrm>
+          <a:prstGeom prst="rect">
+            <a:avLst/>
+          </a:prstGeom>
+        </p:spPr>
+      </p:pic>
     </p:spTree>
   </p:cSld>
   <p:clrMapOvr>

</xml_diff>